<commit_message>
Slides: badged PPTX of sd-09-012
</commit_message>
<xml_diff>
--- a/system-design-101/vi/lessons/sd-09-012/slides/sd-09-012.pptx
+++ b/system-design-101/vi/lessons/sd-09-012/slides/sd-09-012.pptx
@@ -4246,7 +4246,7 @@
               <a:t> hẹp câu</a:t>
             </a:r>
             <a:r>
-              <a:rPr lang="en-US" sz="8400" dirty="0" spc="1" kern="0">
+              <a:rPr lang="en-US" sz="8400" dirty="0" spc="-3" kern="0">
                 <a:solidFill>
                   <a:srgbClr val="14161C"/>
                 </a:solidFill>
@@ -4254,10 +4254,10 @@
                 <a:ea typeface="Bricolage Grotesque ExtraBold" pitchFamily="34" charset="-122"/>
                 <a:cs typeface="Bricolage Grotesque ExtraBold" pitchFamily="34" charset="-120"/>
               </a:rPr>
-              <a:t> hỏi</a:t>
-            </a:r>
-            <a:r>
-              <a:rPr lang="en-US" sz="8400" dirty="0" spc="-94" kern="0">
+              <a:t> hỏi,</a:t>
+            </a:r>
+            <a:r>
+              <a:rPr lang="en-US" sz="8400" dirty="0" spc="-24" kern="0">
                 <a:solidFill>
                   <a:srgbClr val="14161C"/>
                 </a:solidFill>
@@ -4265,10 +4265,10 @@
                 <a:ea typeface="Bricolage Grotesque ExtraBold" pitchFamily="34" charset="-122"/>
                 <a:cs typeface="Bricolage Grotesque ExtraBold" pitchFamily="34" charset="-120"/>
               </a:rPr>
-              <a:t> trước</a:t>
-            </a:r>
-            <a:r>
-              <a:rPr lang="en-US" sz="8400" dirty="0" spc="0" kern="0">
+              <a:t> rồi</a:t>
+            </a:r>
+            <a:r>
+              <a:rPr lang="en-US" sz="8400" dirty="0" spc="-39" kern="0">
                 <a:solidFill>
                   <a:srgbClr val="14161C"/>
                 </a:solidFill>
@@ -4276,10 +4276,10 @@
                 <a:ea typeface="Bricolage Grotesque ExtraBold" pitchFamily="34" charset="-122"/>
                 <a:cs typeface="Bricolage Grotesque ExtraBold" pitchFamily="34" charset="-120"/>
               </a:rPr>
-              <a:t> khi</a:t>
-            </a:r>
-            <a:r>
-              <a:rPr lang="en-US" sz="8400" dirty="0" spc="3" kern="0">
+              <a:t> mới</a:t>
+            </a:r>
+            <a:r>
+              <a:rPr lang="en-US" sz="8400" dirty="0" spc="-54" kern="0">
                 <a:solidFill>
                   <a:srgbClr val="14161C"/>
                 </a:solidFill>
@@ -4287,18 +4287,7 @@
                 <a:ea typeface="Bricolage Grotesque ExtraBold" pitchFamily="34" charset="-122"/>
                 <a:cs typeface="Bricolage Grotesque ExtraBold" pitchFamily="34" charset="-120"/>
               </a:rPr>
-              <a:t> thay</a:t>
-            </a:r>
-            <a:r>
-              <a:rPr lang="en-US" sz="8400" dirty="0" spc="11" kern="0">
-                <a:solidFill>
-                  <a:srgbClr val="14161C"/>
-                </a:solidFill>
-                <a:latin typeface="Bricolage Grotesque ExtraBold" pitchFamily="34" charset="0"/>
-                <a:ea typeface="Bricolage Grotesque ExtraBold" pitchFamily="34" charset="-122"/>
-                <a:cs typeface="Bricolage Grotesque ExtraBold" pitchFamily="34" charset="-120"/>
-              </a:rPr>
-              <a:t> đổi.</a:t>
+              <a:t> sửa.</a:t>
             </a:r>
             <a:endParaRPr lang="en-US" sz="8400" dirty="0"/>
           </a:p>

</xml_diff>

<commit_message>
Slides: name the read-only forms of ip and ss in sd-09-012, re-export PPTX
Co-Authored-By: Claude Opus 5.5 <noreply@anthropic.com>
Claude-Session: https://claude.ai/code/session_014EdyZwPF7XnU2uvEPKZ7Pf
</commit_message>
<xml_diff>
--- a/system-design-101/vi/lessons/sd-09-012/slides/sd-09-012.pptx
+++ b/system-design-101/vi/lessons/sd-09-012/slides/sd-09-012.pptx
@@ -9718,6 +9718,50 @@
               </a:rPr>
               <a:t> SÁT</a:t>
             </a:r>
+            <a:r>
+              <a:rPr lang="en-US" sz="1950" b="1" spc="223" kern="0" dirty="0">
+                <a:solidFill>
+                  <a:srgbClr val="3DD6A0"/>
+                </a:solidFill>
+                <a:latin typeface="Be Vietnam Pro" pitchFamily="34" charset="0"/>
+                <a:ea typeface="Be Vietnam Pro" pitchFamily="34" charset="-122"/>
+                <a:cs typeface="Be Vietnam Pro" pitchFamily="34" charset="-120"/>
+              </a:rPr>
+              <a:t> ·</a:t>
+            </a:r>
+            <a:r>
+              <a:rPr lang="en-US" sz="1950" b="1" spc="209" kern="0" dirty="0">
+                <a:solidFill>
+                  <a:srgbClr val="3DD6A0"/>
+                </a:solidFill>
+                <a:latin typeface="Be Vietnam Pro" pitchFamily="34" charset="0"/>
+                <a:ea typeface="Be Vietnam Pro" pitchFamily="34" charset="-122"/>
+                <a:cs typeface="Be Vietnam Pro" pitchFamily="34" charset="-120"/>
+              </a:rPr>
+              <a:t> DẠNG</a:t>
+            </a:r>
+            <a:r>
+              <a:rPr lang="en-US" sz="1950" b="1" spc="226" kern="0" dirty="0">
+                <a:solidFill>
+                  <a:srgbClr val="3DD6A0"/>
+                </a:solidFill>
+                <a:latin typeface="Be Vietnam Pro" pitchFamily="34" charset="0"/>
+                <a:ea typeface="Be Vietnam Pro" pitchFamily="34" charset="-122"/>
+                <a:cs typeface="Be Vietnam Pro" pitchFamily="34" charset="-120"/>
+              </a:rPr>
+              <a:t> CHỈ</a:t>
+            </a:r>
+            <a:r>
+              <a:rPr lang="en-US" sz="1950" b="1" spc="224" kern="0" dirty="0">
+                <a:solidFill>
+                  <a:srgbClr val="3DD6A0"/>
+                </a:solidFill>
+                <a:latin typeface="Be Vietnam Pro" pitchFamily="34" charset="0"/>
+                <a:ea typeface="Be Vietnam Pro" pitchFamily="34" charset="-122"/>
+                <a:cs typeface="Be Vietnam Pro" pitchFamily="34" charset="-120"/>
+              </a:rPr>
+              <a:t> XEM</a:t>
+            </a:r>
             <a:endParaRPr lang="en-US" sz="1950" dirty="0"/>
           </a:p>
         </p:txBody>
@@ -9848,8 +9892,17 @@
               </a:rPr>
               <a:t> ps</a:t>
             </a:r>
-            <a:r>
-              <a:rPr lang="en-US" sz="3000" dirty="0" spc="3" kern="0">
+            <a:endParaRPr lang="en-US" sz="3000" dirty="0"/>
+          </a:p>
+          <a:p>
+            <a:pPr algn="l" indent="0" marL="0">
+              <a:lnSpc>
+                <a:spcPts val="4200"/>
+              </a:lnSpc>
+              <a:buNone/>
+            </a:pPr>
+            <a:r>
+              <a:rPr lang="en-US" sz="3000" dirty="0" spc="5" kern="0">
                 <a:solidFill>
                   <a:srgbClr val="F3EEE3"/>
                 </a:solidFill>
@@ -9857,10 +9910,10 @@
                 <a:ea typeface="Be Vietnam Pro" pitchFamily="34" charset="-122"/>
                 <a:cs typeface="Be Vietnam Pro" pitchFamily="34" charset="-120"/>
               </a:rPr>
-              <a:t> ·</a:t>
-            </a:r>
-            <a:r>
-              <a:rPr lang="en-US" sz="3000" dirty="0" spc="4" kern="0">
+              <a:t>ip</a:t>
+            </a:r>
+            <a:r>
+              <a:rPr lang="en-US" sz="3000" dirty="0" spc="-14" kern="0">
                 <a:solidFill>
                   <a:srgbClr val="F3EEE3"/>
                 </a:solidFill>
@@ -9868,10 +9921,21 @@
                 <a:ea typeface="Be Vietnam Pro" pitchFamily="34" charset="-122"/>
                 <a:cs typeface="Be Vietnam Pro" pitchFamily="34" charset="-120"/>
               </a:rPr>
-              <a:t> ip</a:t>
-            </a:r>
-            <a:r>
-              <a:rPr lang="en-US" sz="3000" dirty="0" spc="3" kern="0">
+              <a:t> address</a:t>
+            </a:r>
+            <a:r>
+              <a:rPr lang="en-US" sz="3000" dirty="0" spc="-11" kern="0">
+                <a:solidFill>
+                  <a:srgbClr val="F3EEE3"/>
+                </a:solidFill>
+                <a:latin typeface="Be Vietnam Pro" pitchFamily="34" charset="0"/>
+                <a:ea typeface="Be Vietnam Pro" pitchFamily="34" charset="-122"/>
+                <a:cs typeface="Be Vietnam Pro" pitchFamily="34" charset="-120"/>
+              </a:rPr>
+              <a:t> show</a:t>
+            </a:r>
+            <a:r>
+              <a:rPr lang="en-US" sz="3000" dirty="0" spc="1" kern="0">
                 <a:solidFill>
                   <a:srgbClr val="F3EEE3"/>
                 </a:solidFill>

</xml_diff>